<commit_message>
added demos of day 7
</commit_message>
<xml_diff>
--- a/Slides/day-7/Python Scripting for Networking - Day 7.pptx
+++ b/Slides/day-7/Python Scripting for Networking - Day 7.pptx
@@ -251,7 +251,7 @@
           <a:p>
             <a:fld id="{D1D1EADE-8E88-4C7C-8AC5-FB148DE4940E}" type="datetime1">
               <a:rPr lang="en-US" smtClean="0"/>
-              <a:t>6/1/2026</a:t>
+              <a:t>7/14/2026</a:t>
             </a:fld>
             <a:endParaRPr lang="en-US"/>
           </a:p>
@@ -419,7 +419,7 @@
           <a:p>
             <a:fld id="{EC3C8B9C-477D-492A-96AD-1FC2CC997A73}" type="datetime1">
               <a:rPr lang="en-US" smtClean="0"/>
-              <a:t>6/1/2026</a:t>
+              <a:t>7/14/2026</a:t>
             </a:fld>
             <a:endParaRPr lang="en-US"/>
           </a:p>
@@ -597,7 +597,7 @@
           <a:p>
             <a:fld id="{42D3AED5-E26D-4E29-B1B3-7847B6779594}" type="datetime1">
               <a:rPr lang="en-US" smtClean="0"/>
-              <a:t>6/1/2026</a:t>
+              <a:t>7/14/2026</a:t>
             </a:fld>
             <a:endParaRPr lang="en-US"/>
           </a:p>
@@ -765,7 +765,7 @@
           <a:p>
             <a:fld id="{157B6794-849E-4626-908B-D15793550EFB}" type="datetime1">
               <a:rPr lang="en-US" smtClean="0"/>
-              <a:t>6/1/2026</a:t>
+              <a:t>7/14/2026</a:t>
             </a:fld>
             <a:endParaRPr lang="en-US"/>
           </a:p>
@@ -1010,7 +1010,7 @@
           <a:p>
             <a:fld id="{63DB64E7-5594-42A3-ADBF-E95A7ACEAD64}" type="datetime1">
               <a:rPr lang="en-US" smtClean="0"/>
-              <a:t>6/1/2026</a:t>
+              <a:t>7/14/2026</a:t>
             </a:fld>
             <a:endParaRPr lang="en-US"/>
           </a:p>
@@ -1239,7 +1239,7 @@
           <a:p>
             <a:fld id="{18462B0B-D248-4FFB-8695-AD7FA4B1284A}" type="datetime1">
               <a:rPr lang="en-US" smtClean="0"/>
-              <a:t>6/1/2026</a:t>
+              <a:t>7/14/2026</a:t>
             </a:fld>
             <a:endParaRPr lang="en-US"/>
           </a:p>
@@ -1603,7 +1603,7 @@
           <a:p>
             <a:fld id="{D0378EFB-9159-4510-B73F-4F0409ADE937}" type="datetime1">
               <a:rPr lang="en-US" smtClean="0"/>
-              <a:t>6/1/2026</a:t>
+              <a:t>7/14/2026</a:t>
             </a:fld>
             <a:endParaRPr lang="en-US"/>
           </a:p>
@@ -1720,7 +1720,7 @@
           <a:p>
             <a:fld id="{89BC9412-2452-4BED-A324-9D8C115361AD}" type="datetime1">
               <a:rPr lang="en-US" smtClean="0"/>
-              <a:t>6/1/2026</a:t>
+              <a:t>7/14/2026</a:t>
             </a:fld>
             <a:endParaRPr lang="en-US"/>
           </a:p>
@@ -1815,7 +1815,7 @@
           <a:p>
             <a:fld id="{F5318F62-D251-40E8-A23C-F4CFE9FEAB41}" type="datetime1">
               <a:rPr lang="en-US" smtClean="0"/>
-              <a:t>6/1/2026</a:t>
+              <a:t>7/14/2026</a:t>
             </a:fld>
             <a:endParaRPr lang="en-US"/>
           </a:p>
@@ -2090,7 +2090,7 @@
           <a:p>
             <a:fld id="{44F76144-149E-4874-93A5-554A0357CF82}" type="datetime1">
               <a:rPr lang="en-US" smtClean="0"/>
-              <a:t>6/1/2026</a:t>
+              <a:t>7/14/2026</a:t>
             </a:fld>
             <a:endParaRPr lang="en-US"/>
           </a:p>
@@ -2345,7 +2345,7 @@
           <a:p>
             <a:fld id="{50BA65D8-0540-4835-AE5C-25D29DBA01BE}" type="datetime1">
               <a:rPr lang="en-US" smtClean="0"/>
-              <a:t>6/1/2026</a:t>
+              <a:t>7/14/2026</a:t>
             </a:fld>
             <a:endParaRPr lang="en-US"/>
           </a:p>
@@ -2556,7 +2556,7 @@
           <a:p>
             <a:fld id="{E31BA835-12AC-4E8F-955A-EA3F4DE2791F}" type="datetime1">
               <a:rPr lang="en-US" smtClean="0"/>
-              <a:t>6/1/2026</a:t>
+              <a:t>7/14/2026</a:t>
             </a:fld>
             <a:endParaRPr lang="en-US"/>
           </a:p>

</xml_diff>